<commit_message>
optimize gameplay and fix bugs
</commit_message>
<xml_diff>
--- a/Assets/Sprite/DeadwaterImage.pptx
+++ b/Assets/Sprite/DeadwaterImage.pptx
@@ -199,7 +199,7 @@
           <a:p>
             <a:fld id="{5B45DF11-532F-40C8-8B4D-09C9B88A97F4}" type="datetimeFigureOut">
               <a:rPr lang="zh-TW" altLang="en-US" smtClean="0"/>
-              <a:t>2026/3/28</a:t>
+              <a:t>2026/3/29</a:t>
             </a:fld>
             <a:endParaRPr lang="zh-TW" altLang="en-US"/>
           </a:p>
@@ -697,7 +697,7 @@
           <a:p>
             <a:fld id="{95DF18DE-5DA6-4497-A6F9-9E38AEF8B1FA}" type="datetimeFigureOut">
               <a:rPr lang="zh-TW" altLang="en-US" smtClean="0"/>
-              <a:t>2026/3/28</a:t>
+              <a:t>2026/3/29</a:t>
             </a:fld>
             <a:endParaRPr lang="zh-TW" altLang="en-US"/>
           </a:p>
@@ -895,7 +895,7 @@
           <a:p>
             <a:fld id="{95DF18DE-5DA6-4497-A6F9-9E38AEF8B1FA}" type="datetimeFigureOut">
               <a:rPr lang="zh-TW" altLang="en-US" smtClean="0"/>
-              <a:t>2026/3/28</a:t>
+              <a:t>2026/3/29</a:t>
             </a:fld>
             <a:endParaRPr lang="zh-TW" altLang="en-US"/>
           </a:p>
@@ -1103,7 +1103,7 @@
           <a:p>
             <a:fld id="{95DF18DE-5DA6-4497-A6F9-9E38AEF8B1FA}" type="datetimeFigureOut">
               <a:rPr lang="zh-TW" altLang="en-US" smtClean="0"/>
-              <a:t>2026/3/28</a:t>
+              <a:t>2026/3/29</a:t>
             </a:fld>
             <a:endParaRPr lang="zh-TW" altLang="en-US"/>
           </a:p>
@@ -1301,7 +1301,7 @@
           <a:p>
             <a:fld id="{95DF18DE-5DA6-4497-A6F9-9E38AEF8B1FA}" type="datetimeFigureOut">
               <a:rPr lang="zh-TW" altLang="en-US" smtClean="0"/>
-              <a:t>2026/3/28</a:t>
+              <a:t>2026/3/29</a:t>
             </a:fld>
             <a:endParaRPr lang="zh-TW" altLang="en-US"/>
           </a:p>
@@ -1576,7 +1576,7 @@
           <a:p>
             <a:fld id="{95DF18DE-5DA6-4497-A6F9-9E38AEF8B1FA}" type="datetimeFigureOut">
               <a:rPr lang="zh-TW" altLang="en-US" smtClean="0"/>
-              <a:t>2026/3/28</a:t>
+              <a:t>2026/3/29</a:t>
             </a:fld>
             <a:endParaRPr lang="zh-TW" altLang="en-US"/>
           </a:p>
@@ -1841,7 +1841,7 @@
           <a:p>
             <a:fld id="{95DF18DE-5DA6-4497-A6F9-9E38AEF8B1FA}" type="datetimeFigureOut">
               <a:rPr lang="zh-TW" altLang="en-US" smtClean="0"/>
-              <a:t>2026/3/28</a:t>
+              <a:t>2026/3/29</a:t>
             </a:fld>
             <a:endParaRPr lang="zh-TW" altLang="en-US"/>
           </a:p>
@@ -2253,7 +2253,7 @@
           <a:p>
             <a:fld id="{95DF18DE-5DA6-4497-A6F9-9E38AEF8B1FA}" type="datetimeFigureOut">
               <a:rPr lang="zh-TW" altLang="en-US" smtClean="0"/>
-              <a:t>2026/3/28</a:t>
+              <a:t>2026/3/29</a:t>
             </a:fld>
             <a:endParaRPr lang="zh-TW" altLang="en-US"/>
           </a:p>
@@ -2394,7 +2394,7 @@
           <a:p>
             <a:fld id="{95DF18DE-5DA6-4497-A6F9-9E38AEF8B1FA}" type="datetimeFigureOut">
               <a:rPr lang="zh-TW" altLang="en-US" smtClean="0"/>
-              <a:t>2026/3/28</a:t>
+              <a:t>2026/3/29</a:t>
             </a:fld>
             <a:endParaRPr lang="zh-TW" altLang="en-US"/>
           </a:p>
@@ -2507,7 +2507,7 @@
           <a:p>
             <a:fld id="{95DF18DE-5DA6-4497-A6F9-9E38AEF8B1FA}" type="datetimeFigureOut">
               <a:rPr lang="zh-TW" altLang="en-US" smtClean="0"/>
-              <a:t>2026/3/28</a:t>
+              <a:t>2026/3/29</a:t>
             </a:fld>
             <a:endParaRPr lang="zh-TW" altLang="en-US"/>
           </a:p>
@@ -2818,7 +2818,7 @@
           <a:p>
             <a:fld id="{95DF18DE-5DA6-4497-A6F9-9E38AEF8B1FA}" type="datetimeFigureOut">
               <a:rPr lang="zh-TW" altLang="en-US" smtClean="0"/>
-              <a:t>2026/3/28</a:t>
+              <a:t>2026/3/29</a:t>
             </a:fld>
             <a:endParaRPr lang="zh-TW" altLang="en-US"/>
           </a:p>
@@ -3106,7 +3106,7 @@
           <a:p>
             <a:fld id="{95DF18DE-5DA6-4497-A6F9-9E38AEF8B1FA}" type="datetimeFigureOut">
               <a:rPr lang="zh-TW" altLang="en-US" smtClean="0"/>
-              <a:t>2026/3/28</a:t>
+              <a:t>2026/3/29</a:t>
             </a:fld>
             <a:endParaRPr lang="zh-TW" altLang="en-US"/>
           </a:p>
@@ -3347,7 +3347,7 @@
           <a:p>
             <a:fld id="{95DF18DE-5DA6-4497-A6F9-9E38AEF8B1FA}" type="datetimeFigureOut">
               <a:rPr lang="zh-TW" altLang="en-US" smtClean="0"/>
-              <a:t>2026/3/28</a:t>
+              <a:t>2026/3/29</a:t>
             </a:fld>
             <a:endParaRPr lang="zh-TW" altLang="en-US"/>
           </a:p>
@@ -3778,7 +3778,7 @@
         </p:nvSpPr>
         <p:spPr>
           <a:xfrm>
-            <a:off x="378000" y="1137073"/>
+            <a:off x="762353" y="1643607"/>
             <a:ext cx="620643" cy="452967"/>
           </a:xfrm>
           <a:prstGeom prst="triangle">
@@ -3836,7 +3836,7 @@
         </p:nvSpPr>
         <p:spPr>
           <a:xfrm>
-            <a:off x="993121" y="1137072"/>
+            <a:off x="1377474" y="1643606"/>
             <a:ext cx="620643" cy="452967"/>
           </a:xfrm>
           <a:prstGeom prst="triangle">
@@ -3894,7 +3894,7 @@
         </p:nvSpPr>
         <p:spPr>
           <a:xfrm>
-            <a:off x="1608242" y="1137071"/>
+            <a:off x="1992595" y="1643605"/>
             <a:ext cx="620643" cy="452967"/>
           </a:xfrm>
           <a:prstGeom prst="triangle">
@@ -3952,7 +3952,7 @@
         </p:nvSpPr>
         <p:spPr>
           <a:xfrm>
-            <a:off x="2217841" y="1137069"/>
+            <a:off x="2602194" y="1643603"/>
             <a:ext cx="620643" cy="452967"/>
           </a:xfrm>
           <a:prstGeom prst="triangle">
@@ -4010,7 +4010,7 @@
         </p:nvSpPr>
         <p:spPr>
           <a:xfrm>
-            <a:off x="2832962" y="1137065"/>
+            <a:off x="3217315" y="1643599"/>
             <a:ext cx="620643" cy="452967"/>
           </a:xfrm>
           <a:prstGeom prst="triangle">
@@ -4068,7 +4068,7 @@
         </p:nvSpPr>
         <p:spPr>
           <a:xfrm>
-            <a:off x="3453605" y="1137064"/>
+            <a:off x="3837958" y="1643598"/>
             <a:ext cx="620643" cy="452967"/>
           </a:xfrm>
           <a:prstGeom prst="triangle">
@@ -4126,7 +4126,7 @@
         </p:nvSpPr>
         <p:spPr>
           <a:xfrm>
-            <a:off x="4074248" y="1137055"/>
+            <a:off x="4458601" y="1643589"/>
             <a:ext cx="620643" cy="452967"/>
           </a:xfrm>
           <a:prstGeom prst="triangle">
@@ -4184,7 +4184,7 @@
         </p:nvSpPr>
         <p:spPr>
           <a:xfrm>
-            <a:off x="4689369" y="1137037"/>
+            <a:off x="5073722" y="1643571"/>
             <a:ext cx="620643" cy="452967"/>
           </a:xfrm>
           <a:prstGeom prst="triangle">
@@ -4242,7 +4242,7 @@
         </p:nvSpPr>
         <p:spPr>
           <a:xfrm>
-            <a:off x="377559" y="3179233"/>
+            <a:off x="746581" y="2534488"/>
             <a:ext cx="310763" cy="463127"/>
           </a:xfrm>
           <a:custGeom>
@@ -4353,7 +4353,7 @@
         </p:nvSpPr>
         <p:spPr>
           <a:xfrm>
-            <a:off x="682800" y="3179232"/>
+            <a:off x="1051822" y="2534487"/>
             <a:ext cx="620643" cy="452967"/>
           </a:xfrm>
           <a:prstGeom prst="triangle">
@@ -4411,7 +4411,7 @@
         </p:nvSpPr>
         <p:spPr>
           <a:xfrm>
-            <a:off x="1297921" y="3179231"/>
+            <a:off x="1666943" y="2534486"/>
             <a:ext cx="620643" cy="452967"/>
           </a:xfrm>
           <a:prstGeom prst="triangle">
@@ -4469,7 +4469,7 @@
         </p:nvSpPr>
         <p:spPr>
           <a:xfrm>
-            <a:off x="1907520" y="3179229"/>
+            <a:off x="2276542" y="2534484"/>
             <a:ext cx="620643" cy="452967"/>
           </a:xfrm>
           <a:prstGeom prst="triangle">
@@ -4527,7 +4527,7 @@
         </p:nvSpPr>
         <p:spPr>
           <a:xfrm>
-            <a:off x="2522641" y="3179225"/>
+            <a:off x="2891663" y="2534480"/>
             <a:ext cx="620643" cy="452967"/>
           </a:xfrm>
           <a:prstGeom prst="triangle">
@@ -4585,7 +4585,7 @@
         </p:nvSpPr>
         <p:spPr>
           <a:xfrm>
-            <a:off x="3143284" y="3179224"/>
+            <a:off x="3512306" y="2534479"/>
             <a:ext cx="620643" cy="452967"/>
           </a:xfrm>
           <a:prstGeom prst="triangle">
@@ -4643,7 +4643,7 @@
         </p:nvSpPr>
         <p:spPr>
           <a:xfrm>
-            <a:off x="3763927" y="3179215"/>
+            <a:off x="4132949" y="2534470"/>
             <a:ext cx="620643" cy="452967"/>
           </a:xfrm>
           <a:prstGeom prst="triangle">
@@ -4701,7 +4701,7 @@
         </p:nvSpPr>
         <p:spPr>
           <a:xfrm>
-            <a:off x="4379048" y="3179197"/>
+            <a:off x="4748070" y="2534452"/>
             <a:ext cx="620643" cy="452967"/>
           </a:xfrm>
           <a:prstGeom prst="triangle">
@@ -4759,7 +4759,7 @@
         </p:nvSpPr>
         <p:spPr>
           <a:xfrm>
-            <a:off x="6748320" y="1313879"/>
+            <a:off x="5883750" y="1851869"/>
             <a:ext cx="620643" cy="239608"/>
           </a:xfrm>
           <a:prstGeom prst="triangle">
@@ -4817,7 +4817,7 @@
         </p:nvSpPr>
         <p:spPr>
           <a:xfrm>
-            <a:off x="7363441" y="1313878"/>
+            <a:off x="6498871" y="1851868"/>
             <a:ext cx="620643" cy="239608"/>
           </a:xfrm>
           <a:prstGeom prst="triangle">
@@ -4875,7 +4875,7 @@
         </p:nvSpPr>
         <p:spPr>
           <a:xfrm>
-            <a:off x="7978562" y="1313877"/>
+            <a:off x="7113992" y="1851867"/>
             <a:ext cx="620643" cy="239608"/>
           </a:xfrm>
           <a:prstGeom prst="triangle">
@@ -4933,7 +4933,7 @@
         </p:nvSpPr>
         <p:spPr>
           <a:xfrm>
-            <a:off x="8588161" y="1313874"/>
+            <a:off x="7723591" y="1851864"/>
             <a:ext cx="620643" cy="239609"/>
           </a:xfrm>
           <a:prstGeom prst="triangle">
@@ -4991,7 +4991,7 @@
         </p:nvSpPr>
         <p:spPr>
           <a:xfrm>
-            <a:off x="9203282" y="1313871"/>
+            <a:off x="8338712" y="1851861"/>
             <a:ext cx="620643" cy="239608"/>
           </a:xfrm>
           <a:prstGeom prst="triangle">
@@ -5049,7 +5049,7 @@
         </p:nvSpPr>
         <p:spPr>
           <a:xfrm>
-            <a:off x="9823925" y="1313869"/>
+            <a:off x="8959355" y="1851859"/>
             <a:ext cx="620643" cy="239609"/>
           </a:xfrm>
           <a:prstGeom prst="triangle">
@@ -5107,7 +5107,7 @@
         </p:nvSpPr>
         <p:spPr>
           <a:xfrm>
-            <a:off x="10444568" y="1313861"/>
+            <a:off x="9579998" y="1851851"/>
             <a:ext cx="620643" cy="239608"/>
           </a:xfrm>
           <a:prstGeom prst="triangle">
@@ -5165,7 +5165,7 @@
         </p:nvSpPr>
         <p:spPr>
           <a:xfrm>
-            <a:off x="11059689" y="1313842"/>
+            <a:off x="10195119" y="1851832"/>
             <a:ext cx="620643" cy="239609"/>
           </a:xfrm>
           <a:prstGeom prst="triangle">
@@ -5223,7 +5223,7 @@
         </p:nvSpPr>
         <p:spPr>
           <a:xfrm>
-            <a:off x="6759360" y="3392560"/>
+            <a:off x="5883307" y="2737618"/>
             <a:ext cx="310325" cy="244688"/>
           </a:xfrm>
           <a:custGeom>
@@ -5342,7 +5342,7 @@
         </p:nvSpPr>
         <p:spPr>
           <a:xfrm>
-            <a:off x="7064163" y="3392559"/>
+            <a:off x="6188110" y="2737617"/>
             <a:ext cx="620643" cy="239608"/>
           </a:xfrm>
           <a:prstGeom prst="triangle">
@@ -5400,7 +5400,7 @@
         </p:nvSpPr>
         <p:spPr>
           <a:xfrm>
-            <a:off x="7679284" y="3392558"/>
+            <a:off x="6803231" y="2737616"/>
             <a:ext cx="620643" cy="239608"/>
           </a:xfrm>
           <a:prstGeom prst="triangle">
@@ -5458,7 +5458,7 @@
         </p:nvSpPr>
         <p:spPr>
           <a:xfrm>
-            <a:off x="8288883" y="3392555"/>
+            <a:off x="7412830" y="2737613"/>
             <a:ext cx="620643" cy="239609"/>
           </a:xfrm>
           <a:prstGeom prst="triangle">
@@ -5516,7 +5516,7 @@
         </p:nvSpPr>
         <p:spPr>
           <a:xfrm>
-            <a:off x="8904004" y="3392552"/>
+            <a:off x="8027951" y="2737610"/>
             <a:ext cx="620643" cy="239608"/>
           </a:xfrm>
           <a:prstGeom prst="triangle">
@@ -5574,7 +5574,7 @@
         </p:nvSpPr>
         <p:spPr>
           <a:xfrm>
-            <a:off x="9524647" y="3392550"/>
+            <a:off x="8648594" y="2737608"/>
             <a:ext cx="620643" cy="239609"/>
           </a:xfrm>
           <a:prstGeom prst="triangle">
@@ -5632,7 +5632,7 @@
         </p:nvSpPr>
         <p:spPr>
           <a:xfrm>
-            <a:off x="10145290" y="3392542"/>
+            <a:off x="9269237" y="2737600"/>
             <a:ext cx="620643" cy="239608"/>
           </a:xfrm>
           <a:prstGeom prst="triangle">
@@ -5690,7 +5690,7 @@
         </p:nvSpPr>
         <p:spPr>
           <a:xfrm>
-            <a:off x="10760411" y="3392523"/>
+            <a:off x="9884358" y="2737581"/>
             <a:ext cx="620643" cy="239609"/>
           </a:xfrm>
           <a:prstGeom prst="triangle">
@@ -5748,7 +5748,7 @@
         </p:nvSpPr>
         <p:spPr>
           <a:xfrm>
-            <a:off x="11358966" y="3392491"/>
+            <a:off x="10482913" y="2737549"/>
             <a:ext cx="320923" cy="239608"/>
           </a:xfrm>
           <a:custGeom>
@@ -5857,7 +5857,7 @@
         </p:nvSpPr>
         <p:spPr>
           <a:xfrm>
-            <a:off x="5005212" y="3179197"/>
+            <a:off x="5374234" y="2534452"/>
             <a:ext cx="302039" cy="452966"/>
           </a:xfrm>
           <a:custGeom>
@@ -5968,7 +5968,7 @@
         </p:nvSpPr>
         <p:spPr>
           <a:xfrm>
-            <a:off x="382287" y="1584907"/>
+            <a:off x="766640" y="2091441"/>
             <a:ext cx="4932012" cy="363163"/>
           </a:xfrm>
           <a:prstGeom prst="rect">
@@ -6033,7 +6033,7 @@
         </p:nvSpPr>
         <p:spPr>
           <a:xfrm>
-            <a:off x="6747877" y="1544535"/>
+            <a:off x="5883307" y="2082525"/>
             <a:ext cx="4932012" cy="363163"/>
           </a:xfrm>
           <a:prstGeom prst="rect">
@@ -6098,7 +6098,7 @@
         </p:nvSpPr>
         <p:spPr>
           <a:xfrm>
-            <a:off x="6759360" y="3642360"/>
+            <a:off x="5883307" y="2987418"/>
             <a:ext cx="4932012" cy="363163"/>
           </a:xfrm>
           <a:prstGeom prst="rect">
@@ -6163,7 +6163,7 @@
         </p:nvSpPr>
         <p:spPr>
           <a:xfrm>
-            <a:off x="382287" y="3642360"/>
+            <a:off x="751309" y="2997615"/>
             <a:ext cx="4932012" cy="363163"/>
           </a:xfrm>
           <a:prstGeom prst="rect">

</xml_diff>